<commit_message>
Rework LINE rich menu: catalog present replaces customer voice
Co-Authored-By: Claude Opus 5.5 <noreply@anthropic.com>
Claude-Session: https://claude.ai/code/session_012B9C5ZEN3wmcNpkXGGwKaW
</commit_message>
<xml_diff>
--- a/line-account-guide/LINE公式アカウント開設手順書.pptx
+++ b/line-account-guide/LINE公式アカウント開設手順書.pptx
@@ -118,14 +118,14 @@
   <p:extLst>
     <p:ext uri="{521415D9-36F7-43E2-AB2F-B90AF26B5E84}">
       <p14:sectionLst xmlns:p14="http://schemas.microsoft.com/office/powerpoint/2010/main">
-        <p14:section name="はじめに" id="{5eb9dbc8-f66a-5411-c364-d71d587eeca8}">
+        <p14:section name="はじめに" id="{0e93c25f-ddd2-834e-791a-e737d0d80f70}">
           <p14:sldIdLst>
             <p14:sldId id="256"/>
             <p14:sldId id="257"/>
             <p14:sldId id="258"/>
           </p14:sldIdLst>
         </p14:section>
-        <p14:section name="開設手順" id="{e8094888-195f-cdf4-96c0-ecff178b4b5b}">
+        <p14:section name="開設手順" id="{efb8b98b-b901-df48-89e5-a585bbda105a}">
           <p14:sldIdLst>
             <p14:sldId id="259"/>
             <p14:sldId id="260"/>
@@ -135,7 +135,7 @@
             <p14:sldId id="264"/>
           </p14:sldIdLst>
         </p14:section>
-        <p14:section name="開設後" id="{73efb400-c693-4dbb-fa8c-499dd324dde0}">
+        <p14:section name="開設後" id="{0e1553c3-f082-72b5-81e1-9524b4c0b71f}">
           <p14:sldIdLst>
             <p14:sldId id="265"/>
             <p14:sldId id="266"/>
@@ -3577,7 +3577,7 @@
                   <a:schemeClr val="accent4"/>
                 </a:solidFill>
               </a:rPr>
-              <a:t>　お客様の声／見学予約フォーム</a:t>
+              <a:t>　資料請求フォーム／見学予約フォーム</a:t>
             </a:r>
             <a:endParaRPr lang="en-US" sz="1600" dirty="0"/>
           </a:p>
@@ -4143,7 +4143,7 @@
                   <a:schemeClr val="tx2"/>
                 </a:solidFill>
               </a:rPr>
-              <a:t>コンセプト・デザイン・暮らし方・コーディネートを紹介</a:t>
+              <a:t>コンセプト・デザイン・暮らし・インテリアを紹介</a:t>
             </a:r>
             <a:endParaRPr lang="en-US" sz="1400" dirty="0"/>
           </a:p>
@@ -4327,7 +4327,7 @@
                   <a:schemeClr val="tx1"/>
                 </a:solidFill>
               </a:rPr>
-              <a:t>お客様の声</a:t>
+              <a:t>家づくり資料プレゼント</a:t>
             </a:r>
             <a:endParaRPr lang="en-US" sz="1900" dirty="0"/>
           </a:p>
@@ -4363,7 +4363,7 @@
                   <a:schemeClr val="tx2"/>
                 </a:solidFill>
               </a:rPr>
-              <a:t>実際に建てた方の感想や家づくりストーリーを読める</a:t>
+              <a:t>家づくりの資料を申し込める</a:t>
             </a:r>
             <a:endParaRPr lang="en-US" sz="1400" dirty="0"/>
           </a:p>

</xml_diff>

<commit_message>
Simplify rich menu top: ABOUT US, tagline instead of bullet list
Co-Authored-By: Claude Opus 5.5 <noreply@anthropic.com>
Claude-Session: https://claude.ai/code/session_012B9C5ZEN3wmcNpkXGGwKaW
</commit_message>
<xml_diff>
--- a/line-account-guide/LINE公式アカウント開設手順書.pptx
+++ b/line-account-guide/LINE公式アカウント開設手順書.pptx
@@ -118,14 +118,14 @@
   <p:extLst>
     <p:ext uri="{521415D9-36F7-43E2-AB2F-B90AF26B5E84}">
       <p14:sectionLst xmlns:p14="http://schemas.microsoft.com/office/powerpoint/2010/main">
-        <p14:section name="はじめに" id="{0e93c25f-ddd2-834e-791a-e737d0d80f70}">
+        <p14:section name="はじめに" id="{649ec65b-d922-f6ee-e173-ddec06e48ec5}">
           <p14:sldIdLst>
             <p14:sldId id="256"/>
             <p14:sldId id="257"/>
             <p14:sldId id="258"/>
           </p14:sldIdLst>
         </p14:section>
-        <p14:section name="開設手順" id="{efb8b98b-b901-df48-89e5-a585bbda105a}">
+        <p14:section name="開設手順" id="{57c046ff-bf46-4db6-de20-327e3066fa38}">
           <p14:sldIdLst>
             <p14:sldId id="259"/>
             <p14:sldId id="260"/>
@@ -135,7 +135,7 @@
             <p14:sldId id="264"/>
           </p14:sldIdLst>
         </p14:section>
-        <p14:section name="開設後" id="{0e1553c3-f082-72b5-81e1-9524b4c0b71f}">
+        <p14:section name="開設後" id="{cacb3a75-61ff-f530-d485-a614e5e2e127}">
           <p14:sldIdLst>
             <p14:sldId id="265"/>
             <p14:sldId id="266"/>
@@ -4143,7 +4143,7 @@
                   <a:schemeClr val="tx2"/>
                 </a:solidFill>
               </a:rPr>
-              <a:t>コンセプト・デザイン・暮らし・インテリアを紹介</a:t>
+              <a:t>選べるデザイン注文住宅。会社と家づくりの紹介</a:t>
             </a:r>
             <a:endParaRPr lang="en-US" sz="1400" dirty="0"/>
           </a:p>

</xml_diff>

<commit_message>
Add 古河の家 caption to rich menu photo
Co-Authored-By: Claude Opus 5.5 <noreply@anthropic.com>
Claude-Session: https://claude.ai/code/session_012B9C5ZEN3wmcNpkXGGwKaW
</commit_message>
<xml_diff>
--- a/line-account-guide/LINE公式アカウント開設手順書.pptx
+++ b/line-account-guide/LINE公式アカウント開設手順書.pptx
@@ -118,14 +118,14 @@
   <p:extLst>
     <p:ext uri="{521415D9-36F7-43E2-AB2F-B90AF26B5E84}">
       <p14:sectionLst xmlns:p14="http://schemas.microsoft.com/office/powerpoint/2010/main">
-        <p14:section name="はじめに" id="{649ec65b-d922-f6ee-e173-ddec06e48ec5}">
+        <p14:section name="はじめに" id="{d0f1f683-2186-25ef-9263-9d9fed923d3f}">
           <p14:sldIdLst>
             <p14:sldId id="256"/>
             <p14:sldId id="257"/>
             <p14:sldId id="258"/>
           </p14:sldIdLst>
         </p14:section>
-        <p14:section name="開設手順" id="{57c046ff-bf46-4db6-de20-327e3066fa38}">
+        <p14:section name="開設手順" id="{1a299742-5bea-a008-8804-d1a9215b4745}">
           <p14:sldIdLst>
             <p14:sldId id="259"/>
             <p14:sldId id="260"/>
@@ -135,7 +135,7 @@
             <p14:sldId id="264"/>
           </p14:sldIdLst>
         </p14:section>
-        <p14:section name="開設後" id="{cacb3a75-61ff-f530-d485-a614e5e2e127}">
+        <p14:section name="開設後" id="{ef0350b4-d45d-3a2f-fa57-5448958e2e8f}">
           <p14:sldIdLst>
             <p14:sldId id="265"/>
             <p14:sldId id="266"/>

</xml_diff>

<commit_message>
Add open room label to rich menu photo caption
Co-Authored-By: Claude Opus 5.5 <noreply@anthropic.com>
Claude-Session: https://claude.ai/code/session_012B9C5ZEN3wmcNpkXGGwKaW
</commit_message>
<xml_diff>
--- a/line-account-guide/LINE公式アカウント開設手順書.pptx
+++ b/line-account-guide/LINE公式アカウント開設手順書.pptx
@@ -118,14 +118,14 @@
   <p:extLst>
     <p:ext uri="{521415D9-36F7-43E2-AB2F-B90AF26B5E84}">
       <p14:sectionLst xmlns:p14="http://schemas.microsoft.com/office/powerpoint/2010/main">
-        <p14:section name="はじめに" id="{d0f1f683-2186-25ef-9263-9d9fed923d3f}">
+        <p14:section name="はじめに" id="{5b4bbd27-df14-91e0-0b46-3311b95ff647}">
           <p14:sldIdLst>
             <p14:sldId id="256"/>
             <p14:sldId id="257"/>
             <p14:sldId id="258"/>
           </p14:sldIdLst>
         </p14:section>
-        <p14:section name="開設手順" id="{1a299742-5bea-a008-8804-d1a9215b4745}">
+        <p14:section name="開設手順" id="{0838a03f-83c1-02a2-07f9-e30453c87f70}">
           <p14:sldIdLst>
             <p14:sldId id="259"/>
             <p14:sldId id="260"/>
@@ -135,7 +135,7 @@
             <p14:sldId id="264"/>
           </p14:sldIdLst>
         </p14:section>
-        <p14:section name="開設後" id="{ef0350b4-d45d-3a2f-fa57-5448958e2e8f}">
+        <p14:section name="開設後" id="{7f1816cd-896f-8aa8-ab9d-b1a737a0e9e6}">
           <p14:sldIdLst>
             <p14:sldId id="265"/>
             <p14:sldId id="266"/>

</xml_diff>

<commit_message>
Add 新着 badge to rich menu caption, plus NEW! variant
Co-Authored-By: Claude Opus 5.5 <noreply@anthropic.com>
Claude-Session: https://claude.ai/code/session_012B9C5ZEN3wmcNpkXGGwKaW
</commit_message>
<xml_diff>
--- a/line-account-guide/LINE公式アカウント開設手順書.pptx
+++ b/line-account-guide/LINE公式アカウント開設手順書.pptx
@@ -118,14 +118,14 @@
   <p:extLst>
     <p:ext uri="{521415D9-36F7-43E2-AB2F-B90AF26B5E84}">
       <p14:sectionLst xmlns:p14="http://schemas.microsoft.com/office/powerpoint/2010/main">
-        <p14:section name="はじめに" id="{5b4bbd27-df14-91e0-0b46-3311b95ff647}">
+        <p14:section name="はじめに" id="{84315a45-97fb-98f2-6f23-5410c5a5c423}">
           <p14:sldIdLst>
             <p14:sldId id="256"/>
             <p14:sldId id="257"/>
             <p14:sldId id="258"/>
           </p14:sldIdLst>
         </p14:section>
-        <p14:section name="開設手順" id="{0838a03f-83c1-02a2-07f9-e30453c87f70}">
+        <p14:section name="開設手順" id="{d5de8162-ab96-11e7-e486-0d9191726512}">
           <p14:sldIdLst>
             <p14:sldId id="259"/>
             <p14:sldId id="260"/>
@@ -135,7 +135,7 @@
             <p14:sldId id="264"/>
           </p14:sldIdLst>
         </p14:section>
-        <p14:section name="開設後" id="{7f1816cd-896f-8aa8-ab9d-b1a737a0e9e6}">
+        <p14:section name="開設後" id="{6b4656b9-3113-36d3-3b6b-67562aa209a9}">
           <p14:sldIdLst>
             <p14:sldId id="265"/>
             <p14:sldId id="266"/>

</xml_diff>

<commit_message>
Rich menu works tag: ROOM TOUR only
Co-Authored-By: Claude Opus 5.5 <noreply@anthropic.com>
Claude-Session: https://claude.ai/code/session_012B9C5ZEN3wmcNpkXGGwKaW
</commit_message>
<xml_diff>
--- a/line-account-guide/LINE公式アカウント開設手順書.pptx
+++ b/line-account-guide/LINE公式アカウント開設手順書.pptx
@@ -118,14 +118,14 @@
   <p:extLst>
     <p:ext uri="{521415D9-36F7-43E2-AB2F-B90AF26B5E84}">
       <p14:sectionLst xmlns:p14="http://schemas.microsoft.com/office/powerpoint/2010/main">
-        <p14:section name="はじめに" id="{84315a45-97fb-98f2-6f23-5410c5a5c423}">
+        <p14:section name="はじめに" id="{82873903-7ff8-b204-0843-2580733fc116}">
           <p14:sldIdLst>
             <p14:sldId id="256"/>
             <p14:sldId id="257"/>
             <p14:sldId id="258"/>
           </p14:sldIdLst>
         </p14:section>
-        <p14:section name="開設手順" id="{d5de8162-ab96-11e7-e486-0d9191726512}">
+        <p14:section name="開設手順" id="{1d5a5dca-8a44-d1b5-db48-53b46968d1ef}">
           <p14:sldIdLst>
             <p14:sldId id="259"/>
             <p14:sldId id="260"/>
@@ -135,7 +135,7 @@
             <p14:sldId id="264"/>
           </p14:sldIdLst>
         </p14:section>
-        <p14:section name="開設後" id="{6b4656b9-3113-36d3-3b6b-67562aa209a9}">
+        <p14:section name="開設後" id="{6c98399b-3ec5-736d-23f0-2a598e1b2f55}">
           <p14:sldIdLst>
             <p14:sldId id="265"/>
             <p14:sldId id="266"/>
@@ -4253,7 +4253,7 @@
                   <a:schemeClr val="tx2"/>
                 </a:solidFill>
               </a:rPr>
-              <a:t>施工事例と、古河展示場の Room Tour 動画が見られる</a:t>
+              <a:t>施工事例と ROOM TOUR 動画が見られる</a:t>
             </a:r>
             <a:endParaRPr lang="en-US" sz="1400" dirty="0"/>
           </a:p>

</xml_diff>

<commit_message>
Add SORAMA brand name to rich menu photo caption
Co-Authored-By: Claude Opus 5.5 <noreply@anthropic.com>
Claude-Session: https://claude.ai/code/session_012B9C5ZEN3wmcNpkXGGwKaW
</commit_message>
<xml_diff>
--- a/line-account-guide/LINE公式アカウント開設手順書.pptx
+++ b/line-account-guide/LINE公式アカウント開設手順書.pptx
@@ -118,14 +118,14 @@
   <p:extLst>
     <p:ext uri="{521415D9-36F7-43E2-AB2F-B90AF26B5E84}">
       <p14:sectionLst xmlns:p14="http://schemas.microsoft.com/office/powerpoint/2010/main">
-        <p14:section name="はじめに" id="{82873903-7ff8-b204-0843-2580733fc116}">
+        <p14:section name="はじめに" id="{d05bb831-3166-9439-7474-cb89a376ee44}">
           <p14:sldIdLst>
             <p14:sldId id="256"/>
             <p14:sldId id="257"/>
             <p14:sldId id="258"/>
           </p14:sldIdLst>
         </p14:section>
-        <p14:section name="開設手順" id="{1d5a5dca-8a44-d1b5-db48-53b46968d1ef}">
+        <p14:section name="開設手順" id="{107cd3a0-3b12-6a67-60ac-ca5acfc31029}">
           <p14:sldIdLst>
             <p14:sldId id="259"/>
             <p14:sldId id="260"/>
@@ -135,7 +135,7 @@
             <p14:sldId id="264"/>
           </p14:sldIdLst>
         </p14:section>
-        <p14:section name="開設後" id="{6c98399b-3ec5-736d-23f0-2a598e1b2f55}">
+        <p14:section name="開設後" id="{204e99fd-f24e-eb09-ff31-4e8f4a55ea2a}">
           <p14:sldIdLst>
             <p14:sldId id="265"/>
             <p14:sldId id="266"/>

</xml_diff>

<commit_message>
Rich menu brand caption: AMANE (provisional, pending trademark check)
Co-Authored-By: Claude Opus 5.5 <noreply@anthropic.com>
Claude-Session: https://claude.ai/code/session_012B9C5ZEN3wmcNpkXGGwKaW
</commit_message>
<xml_diff>
--- a/line-account-guide/LINE公式アカウント開設手順書.pptx
+++ b/line-account-guide/LINE公式アカウント開設手順書.pptx
@@ -118,14 +118,14 @@
   <p:extLst>
     <p:ext uri="{521415D9-36F7-43E2-AB2F-B90AF26B5E84}">
       <p14:sectionLst xmlns:p14="http://schemas.microsoft.com/office/powerpoint/2010/main">
-        <p14:section name="はじめに" id="{d05bb831-3166-9439-7474-cb89a376ee44}">
+        <p14:section name="はじめに" id="{a11e2f52-fd14-5a0a-990b-a43e3585c0ea}">
           <p14:sldIdLst>
             <p14:sldId id="256"/>
             <p14:sldId id="257"/>
             <p14:sldId id="258"/>
           </p14:sldIdLst>
         </p14:section>
-        <p14:section name="開設手順" id="{107cd3a0-3b12-6a67-60ac-ca5acfc31029}">
+        <p14:section name="開設手順" id="{9d25151c-e086-a3aa-eb61-00be66c6c5b9}">
           <p14:sldIdLst>
             <p14:sldId id="259"/>
             <p14:sldId id="260"/>
@@ -135,7 +135,7 @@
             <p14:sldId id="264"/>
           </p14:sldIdLst>
         </p14:section>
-        <p14:section name="開設後" id="{204e99fd-f24e-eb09-ff31-4e8f4a55ea2a}">
+        <p14:section name="開設後" id="{58d36420-f466-6124-ddeb-1f8d305ee0a6}">
           <p14:sldIdLst>
             <p14:sldId id="265"/>
             <p14:sldId id="266"/>

</xml_diff>

<commit_message>
Rich menu brand caption: AMANOMA
Co-Authored-By: Claude Opus 5.5 <noreply@anthropic.com>
Claude-Session: https://claude.ai/code/session_012B9C5ZEN3wmcNpkXGGwKaW
</commit_message>
<xml_diff>
--- a/line-account-guide/LINE公式アカウント開設手順書.pptx
+++ b/line-account-guide/LINE公式アカウント開設手順書.pptx
@@ -118,14 +118,14 @@
   <p:extLst>
     <p:ext uri="{521415D9-36F7-43E2-AB2F-B90AF26B5E84}">
       <p14:sectionLst xmlns:p14="http://schemas.microsoft.com/office/powerpoint/2010/main">
-        <p14:section name="はじめに" id="{a11e2f52-fd14-5a0a-990b-a43e3585c0ea}">
+        <p14:section name="はじめに" id="{5f92d64c-c1de-9e2c-cc48-73e29dd12bb6}">
           <p14:sldIdLst>
             <p14:sldId id="256"/>
             <p14:sldId id="257"/>
             <p14:sldId id="258"/>
           </p14:sldIdLst>
         </p14:section>
-        <p14:section name="開設手順" id="{9d25151c-e086-a3aa-eb61-00be66c6c5b9}">
+        <p14:section name="開設手順" id="{25521f80-b994-58ff-c42b-948b67125ece}">
           <p14:sldIdLst>
             <p14:sldId id="259"/>
             <p14:sldId id="260"/>
@@ -135,7 +135,7 @@
             <p14:sldId id="264"/>
           </p14:sldIdLst>
         </p14:section>
-        <p14:section name="開設後" id="{58d36420-f466-6124-ddeb-1f8d305ee0a6}">
+        <p14:section name="開設後" id="{e4a08ada-2068-c856-bdd7-97bfea5d0a39}">
           <p14:sldIdLst>
             <p14:sldId id="265"/>
             <p14:sldId id="266"/>

</xml_diff>

<commit_message>
Add AMANOMA tagline to rich menu caption
Co-Authored-By: Claude Opus 5.5 <noreply@anthropic.com>
Claude-Session: https://claude.ai/code/session_012B9C5ZEN3wmcNpkXGGwKaW
</commit_message>
<xml_diff>
--- a/line-account-guide/LINE公式アカウント開設手順書.pptx
+++ b/line-account-guide/LINE公式アカウント開設手順書.pptx
@@ -118,14 +118,14 @@
   <p:extLst>
     <p:ext uri="{521415D9-36F7-43E2-AB2F-B90AF26B5E84}">
       <p14:sectionLst xmlns:p14="http://schemas.microsoft.com/office/powerpoint/2010/main">
-        <p14:section name="はじめに" id="{5f92d64c-c1de-9e2c-cc48-73e29dd12bb6}">
+        <p14:section name="はじめに" id="{59ffae4e-0920-327d-cc1e-21c82066af73}">
           <p14:sldIdLst>
             <p14:sldId id="256"/>
             <p14:sldId id="257"/>
             <p14:sldId id="258"/>
           </p14:sldIdLst>
         </p14:section>
-        <p14:section name="開設手順" id="{25521f80-b994-58ff-c42b-948b67125ece}">
+        <p14:section name="開設手順" id="{8a7a3ec8-fa1a-d581-0e01-f01d58788a73}">
           <p14:sldIdLst>
             <p14:sldId id="259"/>
             <p14:sldId id="260"/>
@@ -135,7 +135,7 @@
             <p14:sldId id="264"/>
           </p14:sldIdLst>
         </p14:section>
-        <p14:section name="開設後" id="{e4a08ada-2068-c856-bdd7-97bfea5d0a39}">
+        <p14:section name="開設後" id="{8e2cb259-99dd-39d5-3b34-26bbc386aa45}">
           <p14:sldIdLst>
             <p14:sldId id="265"/>
             <p14:sldId id="266"/>

</xml_diff>

<commit_message>
CTA wording: 資料を受け取る in rich menu and greeting
Co-Authored-By: Claude Opus 5.5 <noreply@anthropic.com>
Claude-Session: https://claude.ai/code/session_012B9C5ZEN3wmcNpkXGGwKaW
</commit_message>
<xml_diff>
--- a/line-account-guide/LINE公式アカウント開設手順書.pptx
+++ b/line-account-guide/LINE公式アカウント開設手順書.pptx
@@ -118,14 +118,14 @@
   <p:extLst>
     <p:ext uri="{521415D9-36F7-43E2-AB2F-B90AF26B5E84}">
       <p14:sectionLst xmlns:p14="http://schemas.microsoft.com/office/powerpoint/2010/main">
-        <p14:section name="はじめに" id="{59ffae4e-0920-327d-cc1e-21c82066af73}">
+        <p14:section name="はじめに" id="{291d4339-c09b-9fbc-670a-8cf48e51ebe3}">
           <p14:sldIdLst>
             <p14:sldId id="256"/>
             <p14:sldId id="257"/>
             <p14:sldId id="258"/>
           </p14:sldIdLst>
         </p14:section>
-        <p14:section name="開設手順" id="{8a7a3ec8-fa1a-d581-0e01-f01d58788a73}">
+        <p14:section name="開設手順" id="{94db25d5-af20-5b4b-9787-5e8b70c36164}">
           <p14:sldIdLst>
             <p14:sldId id="259"/>
             <p14:sldId id="260"/>
@@ -135,7 +135,7 @@
             <p14:sldId id="264"/>
           </p14:sldIdLst>
         </p14:section>
-        <p14:section name="開設後" id="{8e2cb259-99dd-39d5-3b34-26bbc386aa45}">
+        <p14:section name="開設後" id="{6b64ad71-7d66-c4ec-9646-407872ff18f5}">
           <p14:sldIdLst>
             <p14:sldId id="265"/>
             <p14:sldId id="266"/>

</xml_diff>

<commit_message>
Rename catalog button to 家づくりBOOK
Co-Authored-By: Claude Opus 5.5 <noreply@anthropic.com>
Claude-Session: https://claude.ai/code/session_012B9C5ZEN3wmcNpkXGGwKaW
</commit_message>
<xml_diff>
--- a/line-account-guide/LINE公式アカウント開設手順書.pptx
+++ b/line-account-guide/LINE公式アカウント開設手順書.pptx
@@ -118,14 +118,14 @@
   <p:extLst>
     <p:ext uri="{521415D9-36F7-43E2-AB2F-B90AF26B5E84}">
       <p14:sectionLst xmlns:p14="http://schemas.microsoft.com/office/powerpoint/2010/main">
-        <p14:section name="はじめに" id="{291d4339-c09b-9fbc-670a-8cf48e51ebe3}">
+        <p14:section name="はじめに" id="{f378ee17-c749-c4e4-8a6c-58efe94336a9}">
           <p14:sldIdLst>
             <p14:sldId id="256"/>
             <p14:sldId id="257"/>
             <p14:sldId id="258"/>
           </p14:sldIdLst>
         </p14:section>
-        <p14:section name="開設手順" id="{94db25d5-af20-5b4b-9787-5e8b70c36164}">
+        <p14:section name="開設手順" id="{4f2566ed-bbe0-ddf9-51e0-62476391b8d2}">
           <p14:sldIdLst>
             <p14:sldId id="259"/>
             <p14:sldId id="260"/>
@@ -135,7 +135,7 @@
             <p14:sldId id="264"/>
           </p14:sldIdLst>
         </p14:section>
-        <p14:section name="開設後" id="{6b64ad71-7d66-c4ec-9646-407872ff18f5}">
+        <p14:section name="開設後" id="{8fbc9f71-3e4f-0369-ace0-a0efe6b6006a}">
           <p14:sldIdLst>
             <p14:sldId id="265"/>
             <p14:sldId id="266"/>
@@ -4327,7 +4327,7 @@
                   <a:schemeClr val="tx1"/>
                 </a:solidFill>
               </a:rPr>
-              <a:t>家づくり資料プレゼント</a:t>
+              <a:t>家づくりBOOKプレゼント</a:t>
             </a:r>
             <a:endParaRPr lang="en-US" sz="1900" dirty="0"/>
           </a:p>
@@ -4363,7 +4363,7 @@
                   <a:schemeClr val="tx2"/>
                 </a:solidFill>
               </a:rPr>
-              <a:t>家づくりの資料を申し込める</a:t>
+              <a:t>オリジナル家づくりBOOKを受け取れる</a:t>
             </a:r>
             <a:endParaRPr lang="en-US" sz="1400" dirty="0"/>
           </a:p>

</xml_diff>